<commit_message>
Ask students to open tool accounts before each session
Adds a ready-to-send pre-session message per session, a 'before next
session' section in each booklet, and updated homework slides, scripts and
lecturer checklists so class time goes to creating, not signing up.

Co-Authored-By: Claude Opus 5.5 <noreply@anthropic.com>
Claude-Session: https://claude.ai/code/session_01KYVx18xMYxByYxo559XEXy
</commit_message>
<xml_diff>
--- a/קורס בסיסי AI/שיעור 2/מצגת שיעור 2.pptx
+++ b/קורס בסיסי AI/שיעור 2/מצגת שיעור 2.pptx
@@ -1541,12 +1541,17 @@
           </a:p>
           <a:p>
             <a:r>
+              <a:t>וארבע, חשוב מאוד: פותחים מראש חשבונות חינמיים בכלים של השיעור הבא: Gamma, Canva, HeyGen ו-ElevenLabs. ככה בשיעור לא מבזבזים זמן על הרשמות, רק יוצרים. אשלח לכם הודעה עם כל הקישורים.</a:t>
+            </a:r>
+          </a:p>
+          <a:p>
+            <a:r>
               <a:t>ורמז למפגש הבא: האפיון שלכם הופך למותג, לאפליקציה, למצגת, לתמונת פרופיל, ואפילו לסרטון שבו אתם מדברים. תביאו סלפי טוב.</a:t>
             </a:r>
           </a:p>
           <a:p>
             <a:r>
-              <a:t>(מדביקים את משימת הבית בצ'אט ושולחים במייל)</a:t>
+              <a:t>(מדביקים את משימת הבית בצ'אט. יומיים לפני המפגש הבא שולחים את הודעת ההכנה)</a:t>
             </a:r>
           </a:p>
           <a:p/>
@@ -13305,12 +13310,12 @@
         </p:nvSpPr>
         <p:spPr>
           <a:xfrm>
-            <a:off x="658368" y="1920240"/>
-            <a:ext cx="5120640" cy="3383280"/>
+            <a:off x="11027664" y="4581144"/>
+            <a:ext cx="457200" cy="457200"/>
           </a:xfrm>
           <a:prstGeom prst="roundRect">
             <a:avLst>
-              <a:gd name="adj" fmla="val 3000"/>
+              <a:gd name="adj" fmla="val 20000"/>
             </a:avLst>
           </a:prstGeom>
           <a:solidFill>
@@ -13338,9 +13343,26 @@
           </a:fontRef>
         </p:style>
         <p:txBody>
-          <a:bodyPr rtlCol="0" anchor="ctr"/>
-          <a:lstStyle/>
-          <a:p/>
+          <a:bodyPr rtlCol="0" anchor="ctr" lIns="0" rIns="0" tIns="0" bIns="0"/>
+          <a:lstStyle/>
+          <a:p>
+            <a:pPr rtl="1" algn="ctr" marL="0" indent="0">
+              <a:lnSpc>
+                <a:spcPct val="108000"/>
+              </a:lnSpc>
+              <a:buNone/>
+            </a:pPr>
+            <a:r>
+              <a:rPr sz="1500" b="1" i="0" lang="he-IL">
+                <a:solidFill>
+                  <a:srgbClr val="F2F5FA"/>
+                </a:solidFill>
+                <a:latin typeface="Arial"/>
+                <a:cs typeface="Arial"/>
+              </a:rPr>
+              <a:t>4</a:t>
+            </a:r>
+          </a:p>
         </p:txBody>
       </p:sp>
       <p:sp>
@@ -13351,8 +13373,8 @@
         </p:nvSpPr>
         <p:spPr>
           <a:xfrm>
-            <a:off x="886968" y="2103120"/>
-            <a:ext cx="4663440" cy="365760"/>
+            <a:off x="6309360" y="4608576"/>
+            <a:ext cx="4572000" cy="365760"/>
           </a:xfrm>
           <a:prstGeom prst="rect">
             <a:avLst/>
@@ -13372,14 +13394,14 @@
               <a:buNone/>
             </a:pPr>
             <a:r>
-              <a:rPr sz="1600" b="1" i="0" lang="he-IL">
-                <a:solidFill>
-                  <a:srgbClr val="F2F5FA"/>
+              <a:rPr sz="1700" b="1" i="0" lang="he-IL">
+                <a:solidFill>
+                  <a:srgbClr val="EBEDF0"/>
                 </a:solidFill>
                 <a:latin typeface="Arial"/>
                 <a:cs typeface="Arial"/>
               </a:rPr>
-              <a:t>🔮  רמז למפגש 3</a:t>
+              <a:t>פותחים חשבונות לשיעור הבא</a:t>
             </a:r>
           </a:p>
         </p:txBody>
@@ -13392,8 +13414,8 @@
         </p:nvSpPr>
         <p:spPr>
           <a:xfrm>
-            <a:off x="886968" y="2651760"/>
-            <a:ext cx="4663440" cy="2560320"/>
+            <a:off x="6309360" y="5001768"/>
+            <a:ext cx="4572000" cy="548640"/>
           </a:xfrm>
           <a:prstGeom prst="rect">
             <a:avLst/>
@@ -13408,18 +13430,146 @@
           <a:p>
             <a:pPr rtl="1" algn="r" marL="0" indent="0">
               <a:lnSpc>
-                <a:spcPct val="125000"/>
-              </a:lnSpc>
-              <a:buNone/>
-            </a:pPr>
-            <a:r>
-              <a:rPr sz="1600" b="0" i="0" lang="he-IL">
-                <a:solidFill>
-                  <a:srgbClr val="EBEDF0"/>
+                <a:spcPct val="108000"/>
+              </a:lnSpc>
+              <a:buNone/>
+            </a:pPr>
+            <a:r>
+              <a:rPr sz="1350" b="0" i="0" lang="he-IL">
+                <a:solidFill>
+                  <a:srgbClr val="A9B4C6"/>
                 </a:solidFill>
                 <a:latin typeface="Arial"/>
                 <a:cs typeface="Arial"/>
               </a:rPr>
+              <a:t>Gamma, Canva, HeyGen, ElevenLabs. הקישורים בחוברת</a:t>
+            </a:r>
+          </a:p>
+        </p:txBody>
+      </p:sp>
+      <p:sp>
+        <p:nvSpPr>
+          <p:cNvPr id="16" name="Rounded Rectangle 15"/>
+          <p:cNvSpPr/>
+          <p:nvPr/>
+        </p:nvSpPr>
+        <p:spPr>
+          <a:xfrm>
+            <a:off x="658368" y="1920240"/>
+            <a:ext cx="5120640" cy="3383280"/>
+          </a:xfrm>
+          <a:prstGeom prst="roundRect">
+            <a:avLst>
+              <a:gd name="adj" fmla="val 3000"/>
+            </a:avLst>
+          </a:prstGeom>
+          <a:solidFill>
+            <a:srgbClr val="022349"/>
+          </a:solidFill>
+          <a:ln w="19050">
+            <a:solidFill>
+              <a:srgbClr val="487CFF"/>
+            </a:solidFill>
+          </a:ln>
+          <a:effectLst/>
+        </p:spPr>
+        <p:style>
+          <a:lnRef idx="1">
+            <a:schemeClr val="accent1"/>
+          </a:lnRef>
+          <a:fillRef idx="3">
+            <a:schemeClr val="accent1"/>
+          </a:fillRef>
+          <a:effectRef idx="2">
+            <a:schemeClr val="accent1"/>
+          </a:effectRef>
+          <a:fontRef idx="minor">
+            <a:schemeClr val="lt1"/>
+          </a:fontRef>
+        </p:style>
+        <p:txBody>
+          <a:bodyPr rtlCol="0" anchor="ctr"/>
+          <a:lstStyle/>
+          <a:p/>
+        </p:txBody>
+      </p:sp>
+      <p:sp>
+        <p:nvSpPr>
+          <p:cNvPr id="17" name="TextBox 16"/>
+          <p:cNvSpPr txBox="1"/>
+          <p:nvPr/>
+        </p:nvSpPr>
+        <p:spPr>
+          <a:xfrm>
+            <a:off x="886968" y="2103120"/>
+            <a:ext cx="4663440" cy="365760"/>
+          </a:xfrm>
+          <a:prstGeom prst="rect">
+            <a:avLst/>
+          </a:prstGeom>
+          <a:noFill/>
+        </p:spPr>
+        <p:txBody>
+          <a:bodyPr wrap="square" lIns="0" rIns="0" tIns="0" bIns="0" anchor="t" rtlCol="0">
+            <a:spAutoFit/>
+          </a:bodyPr>
+          <a:lstStyle/>
+          <a:p>
+            <a:pPr rtl="1" algn="r" marL="0" indent="0">
+              <a:lnSpc>
+                <a:spcPct val="108000"/>
+              </a:lnSpc>
+              <a:buNone/>
+            </a:pPr>
+            <a:r>
+              <a:rPr sz="1600" b="1" i="0" lang="he-IL">
+                <a:solidFill>
+                  <a:srgbClr val="F2F5FA"/>
+                </a:solidFill>
+                <a:latin typeface="Arial"/>
+                <a:cs typeface="Arial"/>
+              </a:rPr>
+              <a:t>🔮  רמז למפגש 3</a:t>
+            </a:r>
+          </a:p>
+        </p:txBody>
+      </p:sp>
+      <p:sp>
+        <p:nvSpPr>
+          <p:cNvPr id="18" name="TextBox 17"/>
+          <p:cNvSpPr txBox="1"/>
+          <p:nvPr/>
+        </p:nvSpPr>
+        <p:spPr>
+          <a:xfrm>
+            <a:off x="886968" y="2651760"/>
+            <a:ext cx="4663440" cy="2560320"/>
+          </a:xfrm>
+          <a:prstGeom prst="rect">
+            <a:avLst/>
+          </a:prstGeom>
+          <a:noFill/>
+        </p:spPr>
+        <p:txBody>
+          <a:bodyPr wrap="square" lIns="0" rIns="0" tIns="0" bIns="0" anchor="t" rtlCol="0">
+            <a:spAutoFit/>
+          </a:bodyPr>
+          <a:lstStyle/>
+          <a:p>
+            <a:pPr rtl="1" algn="r" marL="0" indent="0">
+              <a:lnSpc>
+                <a:spcPct val="125000"/>
+              </a:lnSpc>
+              <a:buNone/>
+            </a:pPr>
+            <a:r>
+              <a:rPr sz="1600" b="0" i="0" lang="he-IL">
+                <a:solidFill>
+                  <a:srgbClr val="EBEDF0"/>
+                </a:solidFill>
+                <a:latin typeface="Arial"/>
+                <a:cs typeface="Arial"/>
+              </a:rPr>
               <a:t>האפיון שכתבתם הופך למותג, לאפליקציה, למצגת, לתמונת פרופיל ואפילו לסרטון שבו אתם מדברים. תביאו סלפי טוב.</a:t>
             </a:r>
           </a:p>
@@ -13427,7 +13577,7 @@
       </p:sp>
       <p:sp>
         <p:nvSpPr>
-          <p:cNvPr id="16" name="Rounded Rectangle 15"/>
+          <p:cNvPr id="19" name="Rounded Rectangle 18"/>
           <p:cNvSpPr/>
           <p:nvPr/>
         </p:nvSpPr>
@@ -13471,7 +13621,7 @@
       </p:sp>
       <p:sp>
         <p:nvSpPr>
-          <p:cNvPr id="17" name="TextBox 16"/>
+          <p:cNvPr id="20" name="TextBox 19"/>
           <p:cNvSpPr txBox="1"/>
           <p:nvPr/>
         </p:nvSpPr>
@@ -13505,14 +13655,14 @@
                 <a:latin typeface="Arial"/>
                 <a:cs typeface="Arial"/>
               </a:rPr>
-              <a:t>📤  את האפיון מדביקים גם באפליקציית הקורס. הוא ישמש אותנו בשני המפגשים הבאים.</a:t>
-            </a:r>
-          </a:p>
-        </p:txBody>
-      </p:sp>
-      <p:sp>
-        <p:nvSpPr>
-          <p:cNvPr id="18" name="TextBox 17"/>
+              <a:t>📲  פותחים חשבונות מראש = יותר זמן ליצור בשיעור. הודעה עם כל הקישורים תגיע אליכם לפני המפגש.</a:t>
+            </a:r>
+          </a:p>
+        </p:txBody>
+      </p:sp>
+      <p:sp>
+        <p:nvSpPr>
+          <p:cNvPr id="21" name="TextBox 20"/>
           <p:cNvSpPr txBox="1"/>
           <p:nvPr/>
         </p:nvSpPr>

</xml_diff>

<commit_message>
Session 2: replace non-existent course app with Zoom chat activities and Prompt Lab fallback
Co-Authored-By: Claude Opus 5.5 <noreply@anthropic.com>
Claude-Session: https://claude.ai/code/session_01KYVx18xMYxByYxo559XEXy
</commit_message>
<xml_diff>
--- a/קורס בסיסי AI/שיעור 2/מצגת שיעור 2.pptx
+++ b/קורס בסיסי AI/שיעור 2/מצגת שיעור 2.pptx
@@ -1383,7 +1383,7 @@
           <a:p/>
           <a:p>
             <a:r>
-              <a:t>🏆 אפליקציית הקורס: פותחים את האתגר "מענה למייל עצבני".</a:t>
+              <a:t>🏆 פעילות: אתגר בצ'אט: "מענה למייל עצבני". מקריאים 3 הנחיות מהצ'אט, והכיתה מצביעה בצ'אט: 1, 2 או 3.</a:t>
             </a:r>
           </a:p>
           <a:p/>
@@ -1419,7 +1419,7 @@
           </a:p>
           <a:p>
             <a:r>
-              <a:t>ועכשיו אתגר באפליקציה: אחד המיילים לדוגמה הוא של לקוח עצבני. כתבו את ההנחיה שתוציא ממנו תשובה מושלמת. שלוש דקות.</a:t>
+              <a:t>ועכשיו אתגר: אחד המיילים לדוגמה הוא של לקוח עצבני. כתבו את ההנחיה שתוציא ממנו תשובה מושלמת, ושלחו אותה בצ'אט. שלוש דקות, ואז אקריא שלוש ונצביע.</a:t>
             </a:r>
           </a:p>
           <a:p/>
@@ -1756,7 +1756,7 @@
           <a:p/>
           <a:p>
             <a:r>
-              <a:t>🏆 אפליקציית הקורס: פותחים את האתגר "אפיון העסק שלי במשפט אחד".</a:t>
+              <a:t>🏆 פעילות: אתגר בצ'אט: "העסק שלי במשפט אחד". בוחרים 3 משפטים חדים ומקריאים אותם.</a:t>
             </a:r>
           </a:p>
           <a:p/>
@@ -1817,7 +1817,7 @@
           </a:p>
           <a:p>
             <a:r>
-              <a:t>ובסוף: כתבו באתגר את העסק שלכם במשפט אחד. הכי ברור וחד מנצח.</a:t>
+              <a:t>ובסוף: כתבו בצ'אט את העסק שלכם במשפט אחד. הכי ברור וחד מנצח.</a:t>
             </a:r>
           </a:p>
           <a:p/>
@@ -2026,7 +2026,7 @@
           </a:p>
           <a:p>
             <a:r>
-              <a:t>הם בצ'אט, בחוברת, ובארגז הכלים באפליקציה.</a:t>
+              <a:t>הם בצ'אט ובחוברת.</a:t>
             </a:r>
           </a:p>
           <a:p>
@@ -2352,7 +2352,7 @@
           <a:p/>
           <a:p>
             <a:r>
-              <a:t>🏆 אפליקציית הקורס: פותחים את המשחק ומפעילים את סבב החימום הראשון.</a:t>
+              <a:t>🏆 פעילות: פותחים את Prompt Lab ומפעילים את סבב החימום הראשון. גיבוי: אם המשחק לא עולה תוך דקה, ממשיכים בלי, ומבקשים בצ'אט: "כתבו את ההנחיה הכי גרועה ששלחתם פעם ל-AI".</a:t>
             </a:r>
           </a:p>
           <a:p/>
@@ -3631,7 +3631,7 @@
           <a:p/>
           <a:p>
             <a:r>
-              <a:t>🏆 אפליקציית הקורס: סבב "תקנו את ההנחיה": כל הנחיה חלשה מוצגת, והמשתתפים כותבים תיקון.</a:t>
+              <a:t>🏆 פעילות: סבב "תקנו את ההנחיה" בצ'אט: כל הנחיה חלשה מוצגת, והמשתתפים כותבים תיקון בצ'אט.</a:t>
             </a:r>
           </a:p>
           <a:p/>
@@ -3647,7 +3647,7 @@
           </a:p>
           <a:p>
             <a:r>
-              <a:t>(לפני שחושפים את הפתרון, מציגים כל הנחיה ושואלים: מה הבעיה? כתבו בצ'אט או במשחק)</a:t>
+              <a:t>(לפני שחושפים את הפתרון, מציגים כל הנחיה ושואלים: מה הבעיה? כתבו בצ'אט)</a:t>
             </a:r>
           </a:p>
           <a:p>
@@ -3776,7 +3776,7 @@
           <a:p/>
           <a:p>
             <a:r>
-              <a:t>🏆 אפליקציית הקורס: הצבעה: איזו תוצאה ניצחה, 1 או 2.</a:t>
+              <a:t>🏆 פעילות: הצבעה בצ'אט: כותבים 1 או 2.</a:t>
             </a:r>
           </a:p>
           <a:p/>
@@ -4419,7 +4419,7 @@
           <a:p/>
           <a:p>
             <a:r>
-              <a:t>🏆 אפליקציית הקורס: הצבעה: הנחיית הערב.</a:t>
+              <a:t>🏆 פעילות: הצבעה בצ'אט: מקריאים 3 הנחיות מועמדות, והכיתה כותבת 1, 2 או 3.</a:t>
             </a:r>
           </a:p>
           <a:p/>
@@ -4450,7 +4450,7 @@
           </a:p>
           <a:p>
             <a:r>
-              <a:t>ועכשיו הצבעה: מהי הנחיית הערב? המנצחת נכנסת לבנק של כולם, ואשלח אותה במייל.</a:t>
+              <a:t>ועכשיו הצבעה: מהי הנחיית הערב? אני מקריאה שלוש מועמדות, ואתם כותבים בצ'אט 1, 2 או 3. המנצחת נכנסת לבנק של כולם, ואשלח אותה במייל.</a:t>
             </a:r>
           </a:p>
           <a:p>
@@ -4634,7 +4634,7 @@
           <a:p/>
           <a:p>
             <a:r>
-              <a:t>🏆 אפליקציית הקורס: מציגים את התוצאות הסופיות והמנצחים במשחק.</a:t>
+              <a:t>🏆 פעילות: משתפים את לוח המובילים של Prompt Lab, ומכריזים גם על הנחיית הערב. גיבוי: אם המשחק לא פעל, מכריזים רק על הנחיית הערב.</a:t>
             </a:r>
           </a:p>
           <a:p/>
@@ -4670,7 +4670,7 @@
           </a:p>
           <a:p>
             <a:r>
-              <a:t>(משתפים את לוח התוצאות ומכריזים על המנצחים)</a:t>
+              <a:t>(משתפים את לוח המובילים של Prompt Lab ומכריזים על המנצחים. אם המשחק לא פעל: מכריזים על הנחיית הערב)</a:t>
             </a:r>
           </a:p>
           <a:p>
@@ -11227,7 +11227,7 @@
                 <a:latin typeface="Arial"/>
                 <a:cs typeface="Arial"/>
               </a:rPr>
-              <a:t>🏆  אתגר באפליקציה: "מענה למייל עצבני"</a:t>
+              <a:t>🏆  אתגר בצ'אט: "מענה למייל עצבני"</a:t>
             </a:r>
           </a:p>
         </p:txBody>
@@ -12996,7 +12996,7 @@
                 <a:latin typeface="Arial"/>
                 <a:cs typeface="Arial"/>
               </a:rPr>
-              <a:t>🏆  אתגר באפליקציה: "אפיון העסק שלי במשפט אחד". הכי ברור וחד מנצח.</a:t>
+              <a:t>🏆  אתגר בצ'אט: "העסק שלי במשפט אחד". הכי ברור וחד מנצח.</a:t>
             </a:r>
           </a:p>
         </p:txBody>
@@ -19443,7 +19443,7 @@
                 <a:latin typeface="Arial"/>
                 <a:cs typeface="Arial"/>
               </a:rPr>
-              <a:t>📋  כל הקישורים נמצאים גם בארגז הכלים באפליקציית הקורס ובחוברת.</a:t>
+              <a:t>📋  כל הקישורים נמצאים גם בחוברת.</a:t>
             </a:r>
           </a:p>
         </p:txBody>
@@ -40665,7 +40665,7 @@
                 <a:latin typeface="Arial"/>
                 <a:cs typeface="Arial"/>
               </a:rPr>
-              <a:t>הצבעה במשחק, והמנצחת נכנסת לבנק של כולם</a:t>
+              <a:t>הצבעה בצ'אט, והמנצחת נכנסת לבנק של כולם</a:t>
             </a:r>
           </a:p>
         </p:txBody>

</xml_diff>